<commit_message>
Add real-mode demo video and refresh slides with new features
Co-Authored-By: Devin AI <158243242+devin-ai-integration[bot]@users.noreply.github.com>
</commit_message>
<xml_diff>
--- a/docs/media/video2pr_slides.pptx
+++ b/docs/media/video2pr_slides.pptx
@@ -7,7 +7,11 @@
   <p:sldIdLst>
     <p:sldId id="256" r:id="rId7"/>
     <p:sldId id="257" r:id="rId8"/>
+    <p:sldId id="260" r:id="rId11"/>
     <p:sldId id="258" r:id="rId9"/>
+    <p:sldId id="261" r:id="rId12"/>
+    <p:sldId id="262" r:id="rId13"/>
+    <p:sldId id="263" r:id="rId14"/>
     <p:sldId id="259" r:id="rId10"/>
   </p:sldIdLst>
   <p:sldSz cx="12191695" cy="6858000" type="screen4x3"/>
@@ -3683,7 +3687,7 @@
                 </a:solidFill>
                 <a:latin typeface="Arial"/>
               </a:rPr>
-              <a:t>phone / screen</a:t>
+              <a:t>“Report a bug”</a:t>
             </a:r>
           </a:p>
           <a:p>
@@ -3695,7 +3699,7 @@
                 </a:solidFill>
                 <a:latin typeface="Arial"/>
               </a:rPr>
-              <a:t>recording</a:t>
+              <a:t>button or any file</a:t>
             </a:r>
           </a:p>
         </p:txBody>
@@ -4253,7 +4257,7 @@
                 </a:solidFill>
                 <a:latin typeface="Arial"/>
               </a:rPr>
-              <a:t>FastAPI  ·  ffmpeg  ·  Devin API (structured output + sessions)  ·  vanilla JS frontend</a:t>
+              <a:t>FastAPI  ·  ffmpeg  ·  Devin API v1 (attachments · structured output · sessions)  ·  vanilla JS  ·  parallel sessions</a:t>
             </a:r>
           </a:p>
         </p:txBody>
@@ -4357,7 +4361,7 @@
                 </a:solidFill>
                 <a:latin typeface="Arial"/>
               </a:rPr>
-              <a:t>GT Dining  →  record the bug  →  video2pr</a:t>
+              <a:t>GT Dining  →  “Report a bug”  →  Devin  →  pull request</a:t>
             </a:r>
           </a:p>
         </p:txBody>
@@ -5107,7 +5111,7 @@
                 </a:solidFill>
                 <a:latin typeface="Arial"/>
               </a:rPr>
-              <a:t>• “Record a bug” button in any app</a:t>
+              <a:t>• “Report a bug” button: already built into the demo app</a:t>
             </a:r>
           </a:p>
           <a:p>
@@ -5123,7 +5127,7 @@
                 </a:solidFill>
                 <a:latin typeface="Arial"/>
               </a:rPr>
-              <a:t>• Support desk: customer videos → PRs</a:t>
+              <a:t>• One click: Devin’s report → GitHub issue</a:t>
             </a:r>
           </a:p>
           <a:p>
@@ -5139,7 +5143,7 @@
                 </a:solidFill>
                 <a:latin typeface="Arial"/>
               </a:rPr>
-              <a:t>• QA &amp; beta testers: no ticket writing</a:t>
+              <a:t>• Support desk: customer videos → PRs</a:t>
             </a:r>
           </a:p>
           <a:p>
@@ -5155,7 +5159,7 @@
                 </a:solidFill>
                 <a:latin typeface="Arial"/>
               </a:rPr>
-              <a:t>• Parallel: 4 videos → 4 fixes at once</a:t>
+              <a:t>• Parallel: 4 videos → 4 Devin sessions at once</a:t>
             </a:r>
           </a:p>
         </p:txBody>
@@ -5199,6 +5203,2118 @@
           </a:p>
         </p:txBody>
       </p:sp>
+    </p:spTree>
+  </p:cSld>
+  <p:clrMapOvr>
+    <a:masterClrMapping/>
+  </p:clrMapOvr>
+</p:sld>
+</file>
+
+<file path=ppt/slides/slide5.xml><?xml version="1.0" encoding="utf-8"?>
+<p:sld xmlns:a="http://schemas.openxmlformats.org/drawingml/2006/main" xmlns:p="http://schemas.openxmlformats.org/presentationml/2006/main" xmlns:r="http://schemas.openxmlformats.org/officeDocument/2006/relationships">
+  <p:cSld>
+    <p:bg>
+      <p:bgPr>
+        <a:solidFill>
+          <a:srgbClr val="F8F5EE"/>
+        </a:solidFill>
+        <a:effectLst/>
+      </p:bgPr>
+    </p:bg>
+    <p:spTree>
+      <p:nvGrpSpPr>
+        <p:cNvPr id="1" name=""/>
+        <p:cNvGrpSpPr/>
+        <p:nvPr/>
+      </p:nvGrpSpPr>
+      <p:grpSpPr/>
+      <p:sp>
+        <p:nvSpPr>
+          <p:cNvPr id="2" name="TextBox 1"/>
+          <p:cNvSpPr txBox="1"/>
+          <p:nvPr/>
+        </p:nvSpPr>
+        <p:spPr>
+          <a:xfrm>
+            <a:off x="731520" y="457200"/>
+            <a:ext cx="10058400" cy="457200"/>
+          </a:xfrm>
+          <a:prstGeom prst="rect">
+            <a:avLst/>
+          </a:prstGeom>
+          <a:noFill/>
+        </p:spPr>
+        <p:txBody>
+          <a:bodyPr wrap="square">
+            <a:spAutoFit/>
+          </a:bodyPr>
+          <a:lstStyle/>
+          <a:p>
+            <a:r>
+              <a:rPr sz="1400" b="1">
+                <a:solidFill>
+                  <a:srgbClr val="A58948"/>
+                </a:solidFill>
+                <a:latin typeface="Arial"/>
+              </a:rPr>
+              <a:t>STEP ZERO · INSIDE THE APP</a:t>
+            </a:r>
+          </a:p>
+        </p:txBody>
+      </p:sp>
+      <p:sp>
+        <p:nvSpPr>
+          <p:cNvPr id="3" name="TextBox 2"/>
+          <p:cNvSpPr txBox="1"/>
+          <p:nvPr/>
+        </p:nvSpPr>
+        <p:spPr>
+          <a:xfrm>
+            <a:off x="731520" y="822960"/>
+            <a:ext cx="10789920" cy="914400"/>
+          </a:xfrm>
+          <a:prstGeom prst="rect">
+            <a:avLst/>
+          </a:prstGeom>
+          <a:noFill/>
+        </p:spPr>
+        <p:txBody>
+          <a:bodyPr wrap="square">
+            <a:spAutoFit/>
+          </a:bodyPr>
+          <a:lstStyle/>
+          <a:p>
+            <a:r>
+              <a:rPr sz="4400" b="1">
+                <a:solidFill>
+                  <a:srgbClr val="14253D"/>
+                </a:solidFill>
+                <a:latin typeface="Georgia"/>
+              </a:rPr>
+              <a:t>One click. No ticket.</a:t>
+            </a:r>
+          </a:p>
+        </p:txBody>
+      </p:sp>
+      <p:sp>
+        <p:nvSpPr>
+          <p:cNvPr id="4" name="TextBox 3"/>
+          <p:cNvSpPr txBox="1"/>
+          <p:nvPr/>
+        </p:nvSpPr>
+        <p:spPr>
+          <a:xfrm>
+            <a:off x="731520" y="2011680"/>
+            <a:ext cx="4023360" cy="3657600"/>
+          </a:xfrm>
+          <a:prstGeom prst="rect">
+            <a:avLst/>
+          </a:prstGeom>
+          <a:noFill/>
+        </p:spPr>
+        <p:txBody>
+          <a:bodyPr wrap="square">
+            <a:spAutoFit/>
+          </a:bodyPr>
+          <a:lstStyle/>
+          <a:p>
+            <a:r>
+              <a:rPr sz="2000" b="0">
+                <a:solidFill>
+                  <a:srgbClr val="6B7685"/>
+                </a:solidFill>
+                <a:latin typeface="Arial"/>
+              </a:rPr>
+              <a:t>One click starts a screen recording of the tab.</a:t>
+            </a:r>
+          </a:p>
+          <a:p>
+            <a:pPr>
+              <a:spcBef>
+                <a:spcPts val="900"/>
+              </a:spcBef>
+            </a:pPr>
+            <a:r>
+              <a:rPr sz="2000" b="0">
+                <a:solidFill>
+                  <a:srgbClr val="6B7685"/>
+                </a:solidFill>
+                <a:latin typeface="Arial"/>
+              </a:rPr>
+              <a:t>Stop &amp; send uploads it to video2pr automatically.</a:t>
+            </a:r>
+          </a:p>
+          <a:p>
+            <a:pPr>
+              <a:spcBef>
+                <a:spcPts val="900"/>
+              </a:spcBef>
+            </a:pPr>
+            <a:r>
+              <a:rPr sz="2000" b="0">
+                <a:solidFill>
+                  <a:srgbClr val="6B7685"/>
+                </a:solidFill>
+                <a:latin typeface="Arial"/>
+              </a:rPr>
+              <a:t>No typing. No file to find.</a:t>
+            </a:r>
+          </a:p>
+        </p:txBody>
+      </p:sp>
+      <p:sp>
+        <p:nvSpPr>
+          <p:cNvPr id="5" name="TextBox 4"/>
+          <p:cNvSpPr txBox="1"/>
+          <p:nvPr/>
+        </p:nvSpPr>
+        <p:spPr>
+          <a:xfrm>
+            <a:off x="731520" y="5120640"/>
+            <a:ext cx="4023360" cy="914400"/>
+          </a:xfrm>
+          <a:prstGeom prst="rect">
+            <a:avLst/>
+          </a:prstGeom>
+          <a:noFill/>
+        </p:spPr>
+        <p:txBody>
+          <a:bodyPr wrap="square">
+            <a:spAutoFit/>
+          </a:bodyPr>
+          <a:lstStyle/>
+          <a:p>
+            <a:r>
+              <a:rPr sz="2000" b="1">
+                <a:solidFill>
+                  <a:srgbClr val="14253D"/>
+                </a:solidFill>
+                <a:latin typeface="Arial"/>
+              </a:rPr>
+              <a:t>The user just shows what went wrong.</a:t>
+            </a:r>
+          </a:p>
+        </p:txBody>
+      </p:sp>
+      <p:sp>
+        <p:nvSpPr>
+          <p:cNvPr id="6" name="Rectangle 5"/>
+          <p:cNvSpPr/>
+          <p:nvPr/>
+        </p:nvSpPr>
+        <p:spPr>
+          <a:xfrm>
+            <a:off x="5266944" y="1883664"/>
+            <a:ext cx="6291072" cy="3959352"/>
+          </a:xfrm>
+          <a:prstGeom prst="rect">
+            <a:avLst/>
+          </a:prstGeom>
+          <a:solidFill>
+            <a:srgbClr val="D9D2C3"/>
+          </a:solidFill>
+          <a:ln>
+            <a:noFill/>
+          </a:ln>
+          <a:effectLst/>
+        </p:spPr>
+        <p:style>
+          <a:lnRef idx="1">
+            <a:schemeClr val="accent1"/>
+          </a:lnRef>
+          <a:fillRef idx="3">
+            <a:schemeClr val="accent1"/>
+          </a:fillRef>
+          <a:effectRef idx="2">
+            <a:schemeClr val="accent1"/>
+          </a:effectRef>
+          <a:fontRef idx="minor">
+            <a:schemeClr val="lt1"/>
+          </a:fontRef>
+        </p:style>
+        <p:txBody>
+          <a:bodyPr rtlCol="0" anchor="ctr"/>
+          <a:lstStyle/>
+          <a:p>
+            <a:pPr algn="ctr"/>
+          </a:p>
+        </p:txBody>
+      </p:sp>
+      <p:pic>
+        <p:nvPicPr>
+          <p:cNvPr id="7" name="Picture 6" descr="demo-report-button.png"/>
+          <p:cNvPicPr>
+            <a:picLocks noChangeAspect="1"/>
+          </p:cNvPicPr>
+          <p:nvPr/>
+        </p:nvPicPr>
+        <p:blipFill>
+          <a:blip r:embed="rId2"/>
+          <a:stretch>
+            <a:fillRect/>
+          </a:stretch>
+        </p:blipFill>
+        <p:spPr>
+          <a:xfrm>
+            <a:off x="5303520" y="1920240"/>
+            <a:ext cx="6217920" cy="3886200"/>
+          </a:xfrm>
+          <a:prstGeom prst="rect">
+            <a:avLst/>
+          </a:prstGeom>
+        </p:spPr>
+      </p:pic>
+    </p:spTree>
+  </p:cSld>
+  <p:clrMapOvr>
+    <a:masterClrMapping/>
+  </p:clrMapOvr>
+</p:sld>
+</file>
+
+<file path=ppt/slides/slide6.xml><?xml version="1.0" encoding="utf-8"?>
+<p:sld xmlns:a="http://schemas.openxmlformats.org/drawingml/2006/main" xmlns:p="http://schemas.openxmlformats.org/presentationml/2006/main" xmlns:r="http://schemas.openxmlformats.org/officeDocument/2006/relationships">
+  <p:cSld>
+    <p:bg>
+      <p:bgPr>
+        <a:solidFill>
+          <a:srgbClr val="14253D"/>
+        </a:solidFill>
+        <a:effectLst/>
+      </p:bgPr>
+    </p:bg>
+    <p:spTree>
+      <p:nvGrpSpPr>
+        <p:cNvPr id="1" name=""/>
+        <p:cNvGrpSpPr/>
+        <p:nvPr/>
+      </p:nvGrpSpPr>
+      <p:grpSpPr/>
+      <p:sp>
+        <p:nvSpPr>
+          <p:cNvPr id="2" name="TextBox 1"/>
+          <p:cNvSpPr txBox="1"/>
+          <p:nvPr/>
+        </p:nvSpPr>
+        <p:spPr>
+          <a:xfrm>
+            <a:off x="731520" y="457200"/>
+            <a:ext cx="10058400" cy="457200"/>
+          </a:xfrm>
+          <a:prstGeom prst="rect">
+            <a:avLst/>
+          </a:prstGeom>
+          <a:noFill/>
+        </p:spPr>
+        <p:txBody>
+          <a:bodyPr wrap="square">
+            <a:spAutoFit/>
+          </a:bodyPr>
+          <a:lstStyle/>
+          <a:p>
+            <a:r>
+              <a:rPr sz="1400" b="1">
+                <a:solidFill>
+                  <a:srgbClr val="E9B83E"/>
+                </a:solidFill>
+                <a:latin typeface="Arial"/>
+              </a:rPr>
+              <a:t>REAL RUN · NO MOCK</a:t>
+            </a:r>
+          </a:p>
+        </p:txBody>
+      </p:sp>
+      <p:sp>
+        <p:nvSpPr>
+          <p:cNvPr id="3" name="TextBox 2"/>
+          <p:cNvSpPr txBox="1"/>
+          <p:nvPr/>
+        </p:nvSpPr>
+        <p:spPr>
+          <a:xfrm>
+            <a:off x="731520" y="822960"/>
+            <a:ext cx="10789920" cy="914400"/>
+          </a:xfrm>
+          <a:prstGeom prst="rect">
+            <a:avLst/>
+          </a:prstGeom>
+          <a:noFill/>
+        </p:spPr>
+        <p:txBody>
+          <a:bodyPr wrap="square">
+            <a:spAutoFit/>
+          </a:bodyPr>
+          <a:lstStyle/>
+          <a:p>
+            <a:r>
+              <a:rPr sz="4400" b="1">
+                <a:solidFill>
+                  <a:srgbClr val="FFFFFF"/>
+                </a:solidFill>
+                <a:latin typeface="Georgia"/>
+              </a:rPr>
+              <a:t>Video → PR in 1m 24s.</a:t>
+            </a:r>
+          </a:p>
+        </p:txBody>
+      </p:sp>
+      <p:sp>
+        <p:nvSpPr>
+          <p:cNvPr id="4" name="Rounded Rectangle 3"/>
+          <p:cNvSpPr/>
+          <p:nvPr/>
+        </p:nvSpPr>
+        <p:spPr>
+          <a:xfrm>
+            <a:off x="731520" y="1965960"/>
+            <a:ext cx="1143000" cy="822960"/>
+          </a:xfrm>
+          <a:prstGeom prst="roundRect">
+            <a:avLst>
+              <a:gd name="adj" fmla="val 18000"/>
+            </a:avLst>
+          </a:prstGeom>
+          <a:solidFill>
+            <a:srgbClr val="E9B83E"/>
+          </a:solidFill>
+          <a:ln>
+            <a:noFill/>
+          </a:ln>
+          <a:effectLst/>
+        </p:spPr>
+        <p:style>
+          <a:lnRef idx="1">
+            <a:schemeClr val="accent1"/>
+          </a:lnRef>
+          <a:fillRef idx="3">
+            <a:schemeClr val="accent1"/>
+          </a:fillRef>
+          <a:effectRef idx="2">
+            <a:schemeClr val="accent1"/>
+          </a:effectRef>
+          <a:fontRef idx="minor">
+            <a:schemeClr val="lt1"/>
+          </a:fontRef>
+        </p:style>
+        <p:txBody>
+          <a:bodyPr rtlCol="0" anchor="ctr"/>
+          <a:lstStyle/>
+          <a:p>
+            <a:pPr algn="ctr"/>
+          </a:p>
+        </p:txBody>
+      </p:sp>
+      <p:sp>
+        <p:nvSpPr>
+          <p:cNvPr id="5" name="TextBox 4"/>
+          <p:cNvSpPr txBox="1"/>
+          <p:nvPr/>
+        </p:nvSpPr>
+        <p:spPr>
+          <a:xfrm>
+            <a:off x="731520" y="1965960"/>
+            <a:ext cx="1143000" cy="822960"/>
+          </a:xfrm>
+          <a:prstGeom prst="rect">
+            <a:avLst/>
+          </a:prstGeom>
+          <a:noFill/>
+        </p:spPr>
+        <p:txBody>
+          <a:bodyPr wrap="square" anchor="ctr">
+            <a:spAutoFit/>
+          </a:bodyPr>
+          <a:lstStyle/>
+          <a:p>
+            <a:pPr algn="ctr"/>
+            <a:r>
+              <a:rPr sz="2400" b="1">
+                <a:solidFill>
+                  <a:srgbClr val="14253D"/>
+                </a:solidFill>
+                <a:latin typeface="Arial"/>
+              </a:rPr>
+              <a:t>0:00</a:t>
+            </a:r>
+          </a:p>
+        </p:txBody>
+      </p:sp>
+      <p:sp>
+        <p:nvSpPr>
+          <p:cNvPr id="6" name="TextBox 5"/>
+          <p:cNvSpPr txBox="1"/>
+          <p:nvPr/>
+        </p:nvSpPr>
+        <p:spPr>
+          <a:xfrm>
+            <a:off x="2057400" y="1984248"/>
+            <a:ext cx="3840480" cy="411480"/>
+          </a:xfrm>
+          <a:prstGeom prst="rect">
+            <a:avLst/>
+          </a:prstGeom>
+          <a:noFill/>
+        </p:spPr>
+        <p:txBody>
+          <a:bodyPr wrap="square">
+            <a:spAutoFit/>
+          </a:bodyPr>
+          <a:lstStyle/>
+          <a:p>
+            <a:r>
+              <a:rPr sz="2000" b="1">
+                <a:solidFill>
+                  <a:srgbClr val="FFFFFF"/>
+                </a:solidFill>
+                <a:latin typeface="Arial"/>
+              </a:rPr>
+              <a:t>Recording sent</a:t>
+            </a:r>
+          </a:p>
+        </p:txBody>
+      </p:sp>
+      <p:sp>
+        <p:nvSpPr>
+          <p:cNvPr id="7" name="TextBox 6"/>
+          <p:cNvSpPr txBox="1"/>
+          <p:nvPr/>
+        </p:nvSpPr>
+        <p:spPr>
+          <a:xfrm>
+            <a:off x="2057400" y="2377440"/>
+            <a:ext cx="3840480" cy="411480"/>
+          </a:xfrm>
+          <a:prstGeom prst="rect">
+            <a:avLst/>
+          </a:prstGeom>
+          <a:noFill/>
+        </p:spPr>
+        <p:txBody>
+          <a:bodyPr wrap="square">
+            <a:spAutoFit/>
+          </a:bodyPr>
+          <a:lstStyle/>
+          <a:p>
+            <a:r>
+              <a:rPr sz="1400" b="0">
+                <a:solidFill>
+                  <a:srgbClr val="C9D2DE"/>
+                </a:solidFill>
+                <a:latin typeface="Arial"/>
+              </a:rPr>
+              <a:t>from the “Report a bug” button</a:t>
+            </a:r>
+          </a:p>
+        </p:txBody>
+      </p:sp>
+      <p:sp>
+        <p:nvSpPr>
+          <p:cNvPr id="8" name="Rounded Rectangle 7"/>
+          <p:cNvSpPr/>
+          <p:nvPr/>
+        </p:nvSpPr>
+        <p:spPr>
+          <a:xfrm>
+            <a:off x="731520" y="2999232"/>
+            <a:ext cx="1143000" cy="822960"/>
+          </a:xfrm>
+          <a:prstGeom prst="roundRect">
+            <a:avLst>
+              <a:gd name="adj" fmla="val 18000"/>
+            </a:avLst>
+          </a:prstGeom>
+          <a:solidFill>
+            <a:srgbClr val="E9B83E"/>
+          </a:solidFill>
+          <a:ln>
+            <a:noFill/>
+          </a:ln>
+          <a:effectLst/>
+        </p:spPr>
+        <p:style>
+          <a:lnRef idx="1">
+            <a:schemeClr val="accent1"/>
+          </a:lnRef>
+          <a:fillRef idx="3">
+            <a:schemeClr val="accent1"/>
+          </a:fillRef>
+          <a:effectRef idx="2">
+            <a:schemeClr val="accent1"/>
+          </a:effectRef>
+          <a:fontRef idx="minor">
+            <a:schemeClr val="lt1"/>
+          </a:fontRef>
+        </p:style>
+        <p:txBody>
+          <a:bodyPr rtlCol="0" anchor="ctr"/>
+          <a:lstStyle/>
+          <a:p>
+            <a:pPr algn="ctr"/>
+          </a:p>
+        </p:txBody>
+      </p:sp>
+      <p:sp>
+        <p:nvSpPr>
+          <p:cNvPr id="9" name="TextBox 8"/>
+          <p:cNvSpPr txBox="1"/>
+          <p:nvPr/>
+        </p:nvSpPr>
+        <p:spPr>
+          <a:xfrm>
+            <a:off x="731520" y="2999232"/>
+            <a:ext cx="1143000" cy="822960"/>
+          </a:xfrm>
+          <a:prstGeom prst="rect">
+            <a:avLst/>
+          </a:prstGeom>
+          <a:noFill/>
+        </p:spPr>
+        <p:txBody>
+          <a:bodyPr wrap="square" anchor="ctr">
+            <a:spAutoFit/>
+          </a:bodyPr>
+          <a:lstStyle/>
+          <a:p>
+            <a:pPr algn="ctr"/>
+            <a:r>
+              <a:rPr sz="2400" b="1">
+                <a:solidFill>
+                  <a:srgbClr val="14253D"/>
+                </a:solidFill>
+                <a:latin typeface="Arial"/>
+              </a:rPr>
+              <a:t>0:33</a:t>
+            </a:r>
+          </a:p>
+        </p:txBody>
+      </p:sp>
+      <p:sp>
+        <p:nvSpPr>
+          <p:cNvPr id="10" name="TextBox 9"/>
+          <p:cNvSpPr txBox="1"/>
+          <p:nvPr/>
+        </p:nvSpPr>
+        <p:spPr>
+          <a:xfrm>
+            <a:off x="2057400" y="3017520"/>
+            <a:ext cx="3840480" cy="411480"/>
+          </a:xfrm>
+          <a:prstGeom prst="rect">
+            <a:avLst/>
+          </a:prstGeom>
+          <a:noFill/>
+        </p:spPr>
+        <p:txBody>
+          <a:bodyPr wrap="square">
+            <a:spAutoFit/>
+          </a:bodyPr>
+          <a:lstStyle/>
+          <a:p>
+            <a:r>
+              <a:rPr sz="2000" b="1">
+                <a:solidFill>
+                  <a:srgbClr val="FFFFFF"/>
+                </a:solidFill>
+                <a:latin typeface="Arial"/>
+              </a:rPr>
+              <a:t>Devin writes the bug report</a:t>
+            </a:r>
+          </a:p>
+        </p:txBody>
+      </p:sp>
+      <p:sp>
+        <p:nvSpPr>
+          <p:cNvPr id="11" name="TextBox 10"/>
+          <p:cNvSpPr txBox="1"/>
+          <p:nvPr/>
+        </p:nvSpPr>
+        <p:spPr>
+          <a:xfrm>
+            <a:off x="2057400" y="3410712"/>
+            <a:ext cx="3840480" cy="411480"/>
+          </a:xfrm>
+          <a:prstGeom prst="rect">
+            <a:avLst/>
+          </a:prstGeom>
+          <a:noFill/>
+        </p:spPr>
+        <p:txBody>
+          <a:bodyPr wrap="square">
+            <a:spAutoFit/>
+          </a:bodyPr>
+          <a:lstStyle/>
+          <a:p>
+            <a:r>
+              <a:rPr sz="1400" b="0">
+                <a:solidFill>
+                  <a:srgbClr val="C9D2DE"/>
+                </a:solidFill>
+                <a:latin typeface="Arial"/>
+              </a:rPr>
+              <a:t>from the screenshots alone, no text hint</a:t>
+            </a:r>
+          </a:p>
+        </p:txBody>
+      </p:sp>
+      <p:sp>
+        <p:nvSpPr>
+          <p:cNvPr id="12" name="Rounded Rectangle 11"/>
+          <p:cNvSpPr/>
+          <p:nvPr/>
+        </p:nvSpPr>
+        <p:spPr>
+          <a:xfrm>
+            <a:off x="731520" y="4032504"/>
+            <a:ext cx="1143000" cy="822960"/>
+          </a:xfrm>
+          <a:prstGeom prst="roundRect">
+            <a:avLst>
+              <a:gd name="adj" fmla="val 18000"/>
+            </a:avLst>
+          </a:prstGeom>
+          <a:solidFill>
+            <a:srgbClr val="E9B83E"/>
+          </a:solidFill>
+          <a:ln>
+            <a:noFill/>
+          </a:ln>
+          <a:effectLst/>
+        </p:spPr>
+        <p:style>
+          <a:lnRef idx="1">
+            <a:schemeClr val="accent1"/>
+          </a:lnRef>
+          <a:fillRef idx="3">
+            <a:schemeClr val="accent1"/>
+          </a:fillRef>
+          <a:effectRef idx="2">
+            <a:schemeClr val="accent1"/>
+          </a:effectRef>
+          <a:fontRef idx="minor">
+            <a:schemeClr val="lt1"/>
+          </a:fontRef>
+        </p:style>
+        <p:txBody>
+          <a:bodyPr rtlCol="0" anchor="ctr"/>
+          <a:lstStyle/>
+          <a:p>
+            <a:pPr algn="ctr"/>
+          </a:p>
+        </p:txBody>
+      </p:sp>
+      <p:sp>
+        <p:nvSpPr>
+          <p:cNvPr id="13" name="TextBox 12"/>
+          <p:cNvSpPr txBox="1"/>
+          <p:nvPr/>
+        </p:nvSpPr>
+        <p:spPr>
+          <a:xfrm>
+            <a:off x="731520" y="4032504"/>
+            <a:ext cx="1143000" cy="822960"/>
+          </a:xfrm>
+          <a:prstGeom prst="rect">
+            <a:avLst/>
+          </a:prstGeom>
+          <a:noFill/>
+        </p:spPr>
+        <p:txBody>
+          <a:bodyPr wrap="square" anchor="ctr">
+            <a:spAutoFit/>
+          </a:bodyPr>
+          <a:lstStyle/>
+          <a:p>
+            <a:pPr algn="ctr"/>
+            <a:r>
+              <a:rPr sz="2400" b="1">
+                <a:solidFill>
+                  <a:srgbClr val="14253D"/>
+                </a:solidFill>
+                <a:latin typeface="Arial"/>
+              </a:rPr>
+              <a:t>1:24</a:t>
+            </a:r>
+          </a:p>
+        </p:txBody>
+      </p:sp>
+      <p:sp>
+        <p:nvSpPr>
+          <p:cNvPr id="14" name="TextBox 13"/>
+          <p:cNvSpPr txBox="1"/>
+          <p:nvPr/>
+        </p:nvSpPr>
+        <p:spPr>
+          <a:xfrm>
+            <a:off x="2057400" y="4050791"/>
+            <a:ext cx="3840480" cy="411480"/>
+          </a:xfrm>
+          <a:prstGeom prst="rect">
+            <a:avLst/>
+          </a:prstGeom>
+          <a:noFill/>
+        </p:spPr>
+        <p:txBody>
+          <a:bodyPr wrap="square">
+            <a:spAutoFit/>
+          </a:bodyPr>
+          <a:lstStyle/>
+          <a:p>
+            <a:r>
+              <a:rPr sz="2000" b="1">
+                <a:solidFill>
+                  <a:srgbClr val="FFFFFF"/>
+                </a:solidFill>
+                <a:latin typeface="Arial"/>
+              </a:rPr>
+              <a:t>Devin opens the pull request</a:t>
+            </a:r>
+          </a:p>
+        </p:txBody>
+      </p:sp>
+      <p:sp>
+        <p:nvSpPr>
+          <p:cNvPr id="15" name="TextBox 14"/>
+          <p:cNvSpPr txBox="1"/>
+          <p:nvPr/>
+        </p:nvSpPr>
+        <p:spPr>
+          <a:xfrm>
+            <a:off x="2057400" y="4443984"/>
+            <a:ext cx="3840480" cy="411480"/>
+          </a:xfrm>
+          <a:prstGeom prst="rect">
+            <a:avLst/>
+          </a:prstGeom>
+          <a:noFill/>
+        </p:spPr>
+        <p:txBody>
+          <a:bodyPr wrap="square">
+            <a:spAutoFit/>
+          </a:bodyPr>
+          <a:lstStyle/>
+          <a:p>
+            <a:r>
+              <a:rPr sz="1400" b="0">
+                <a:solidFill>
+                  <a:srgbClr val="C9D2DE"/>
+                </a:solidFill>
+                <a:latin typeface="Arial"/>
+              </a:rPr>
+              <a:t>after reproducing and fixing in a browser</a:t>
+            </a:r>
+          </a:p>
+        </p:txBody>
+      </p:sp>
+      <p:sp>
+        <p:nvSpPr>
+          <p:cNvPr id="16" name="Rounded Rectangle 15"/>
+          <p:cNvSpPr/>
+          <p:nvPr/>
+        </p:nvSpPr>
+        <p:spPr>
+          <a:xfrm>
+            <a:off x="731520" y="5065776"/>
+            <a:ext cx="1143000" cy="822960"/>
+          </a:xfrm>
+          <a:prstGeom prst="roundRect">
+            <a:avLst>
+              <a:gd name="adj" fmla="val 18000"/>
+            </a:avLst>
+          </a:prstGeom>
+          <a:solidFill>
+            <a:srgbClr val="E9B83E"/>
+          </a:solidFill>
+          <a:ln>
+            <a:noFill/>
+          </a:ln>
+          <a:effectLst/>
+        </p:spPr>
+        <p:style>
+          <a:lnRef idx="1">
+            <a:schemeClr val="accent1"/>
+          </a:lnRef>
+          <a:fillRef idx="3">
+            <a:schemeClr val="accent1"/>
+          </a:fillRef>
+          <a:effectRef idx="2">
+            <a:schemeClr val="accent1"/>
+          </a:effectRef>
+          <a:fontRef idx="minor">
+            <a:schemeClr val="lt1"/>
+          </a:fontRef>
+        </p:style>
+        <p:txBody>
+          <a:bodyPr rtlCol="0" anchor="ctr"/>
+          <a:lstStyle/>
+          <a:p>
+            <a:pPr algn="ctr"/>
+          </a:p>
+        </p:txBody>
+      </p:sp>
+      <p:sp>
+        <p:nvSpPr>
+          <p:cNvPr id="17" name="TextBox 16"/>
+          <p:cNvSpPr txBox="1"/>
+          <p:nvPr/>
+        </p:nvSpPr>
+        <p:spPr>
+          <a:xfrm>
+            <a:off x="731520" y="5065776"/>
+            <a:ext cx="1143000" cy="822960"/>
+          </a:xfrm>
+          <a:prstGeom prst="rect">
+            <a:avLst/>
+          </a:prstGeom>
+          <a:noFill/>
+        </p:spPr>
+        <p:txBody>
+          <a:bodyPr wrap="square" anchor="ctr">
+            <a:spAutoFit/>
+          </a:bodyPr>
+          <a:lstStyle/>
+          <a:p>
+            <a:pPr algn="ctr"/>
+            <a:r>
+              <a:rPr sz="2400" b="1">
+                <a:solidFill>
+                  <a:srgbClr val="14253D"/>
+                </a:solidFill>
+                <a:latin typeface="Arial"/>
+              </a:rPr>
+              <a:t>1:56</a:t>
+            </a:r>
+          </a:p>
+        </p:txBody>
+      </p:sp>
+      <p:sp>
+        <p:nvSpPr>
+          <p:cNvPr id="18" name="TextBox 17"/>
+          <p:cNvSpPr txBox="1"/>
+          <p:nvPr/>
+        </p:nvSpPr>
+        <p:spPr>
+          <a:xfrm>
+            <a:off x="2057400" y="5084064"/>
+            <a:ext cx="3840480" cy="411480"/>
+          </a:xfrm>
+          <a:prstGeom prst="rect">
+            <a:avLst/>
+          </a:prstGeom>
+          <a:noFill/>
+        </p:spPr>
+        <p:txBody>
+          <a:bodyPr wrap="square">
+            <a:spAutoFit/>
+          </a:bodyPr>
+          <a:lstStyle/>
+          <a:p>
+            <a:r>
+              <a:rPr sz="2000" b="1">
+                <a:solidFill>
+                  <a:srgbClr val="FFFFFF"/>
+                </a:solidFill>
+                <a:latin typeface="Arial"/>
+              </a:rPr>
+              <a:t>Before / after verified</a:t>
+            </a:r>
+          </a:p>
+        </p:txBody>
+      </p:sp>
+      <p:sp>
+        <p:nvSpPr>
+          <p:cNvPr id="19" name="TextBox 18"/>
+          <p:cNvSpPr txBox="1"/>
+          <p:nvPr/>
+        </p:nvSpPr>
+        <p:spPr>
+          <a:xfrm>
+            <a:off x="2057400" y="5477256"/>
+            <a:ext cx="3840480" cy="411480"/>
+          </a:xfrm>
+          <a:prstGeom prst="rect">
+            <a:avLst/>
+          </a:prstGeom>
+          <a:noFill/>
+        </p:spPr>
+        <p:txBody>
+          <a:bodyPr wrap="square">
+            <a:spAutoFit/>
+          </a:bodyPr>
+          <a:lstStyle/>
+          <a:p>
+            <a:r>
+              <a:rPr sz="1400" b="0">
+                <a:solidFill>
+                  <a:srgbClr val="C9D2DE"/>
+                </a:solidFill>
+                <a:latin typeface="Arial"/>
+              </a:rPr>
+              <a:t>screenshots, root cause and diff on the page</a:t>
+            </a:r>
+          </a:p>
+        </p:txBody>
+      </p:sp>
+      <p:pic>
+        <p:nvPicPr>
+          <p:cNvPr id="20" name="Picture 19" descr="c_report.png"/>
+          <p:cNvPicPr>
+            <a:picLocks noChangeAspect="1"/>
+          </p:cNvPicPr>
+          <p:nvPr/>
+        </p:nvPicPr>
+        <p:blipFill>
+          <a:blip r:embed="rId2"/>
+          <a:stretch>
+            <a:fillRect/>
+          </a:stretch>
+        </p:blipFill>
+        <p:spPr>
+          <a:xfrm>
+            <a:off x="6172200" y="1874519"/>
+            <a:ext cx="5394960" cy="3927530"/>
+          </a:xfrm>
+          <a:prstGeom prst="rect">
+            <a:avLst/>
+          </a:prstGeom>
+        </p:spPr>
+      </p:pic>
+      <p:sp>
+        <p:nvSpPr>
+          <p:cNvPr id="21" name="TextBox 20"/>
+          <p:cNvSpPr txBox="1"/>
+          <p:nvPr/>
+        </p:nvSpPr>
+        <p:spPr>
+          <a:xfrm>
+            <a:off x="731520" y="6172200"/>
+            <a:ext cx="5486400" cy="365760"/>
+          </a:xfrm>
+          <a:prstGeom prst="rect">
+            <a:avLst/>
+          </a:prstGeom>
+          <a:noFill/>
+        </p:spPr>
+        <p:txBody>
+          <a:bodyPr wrap="square">
+            <a:spAutoFit/>
+          </a:bodyPr>
+          <a:lstStyle/>
+          <a:p>
+            <a:r>
+              <a:rPr sz="1200" b="0">
+                <a:solidFill>
+                  <a:srgbClr val="8E9BAE"/>
+                </a:solidFill>
+                <a:latin typeface="Arial"/>
+              </a:rPr>
+              <a:t>Real Devin session on this repo · PR #14</a:t>
+            </a:r>
+          </a:p>
+        </p:txBody>
+      </p:sp>
+    </p:spTree>
+  </p:cSld>
+  <p:clrMapOvr>
+    <a:masterClrMapping/>
+  </p:clrMapOvr>
+</p:sld>
+</file>
+
+<file path=ppt/slides/slide7.xml><?xml version="1.0" encoding="utf-8"?>
+<p:sld xmlns:a="http://schemas.openxmlformats.org/drawingml/2006/main" xmlns:p="http://schemas.openxmlformats.org/presentationml/2006/main" xmlns:r="http://schemas.openxmlformats.org/officeDocument/2006/relationships">
+  <p:cSld>
+    <p:bg>
+      <p:bgPr>
+        <a:solidFill>
+          <a:srgbClr val="F8F5EE"/>
+        </a:solidFill>
+        <a:effectLst/>
+      </p:bgPr>
+    </p:bg>
+    <p:spTree>
+      <p:nvGrpSpPr>
+        <p:cNvPr id="1" name=""/>
+        <p:cNvGrpSpPr/>
+        <p:nvPr/>
+      </p:nvGrpSpPr>
+      <p:grpSpPr/>
+      <p:sp>
+        <p:nvSpPr>
+          <p:cNvPr id="2" name="TextBox 1"/>
+          <p:cNvSpPr txBox="1"/>
+          <p:nvPr/>
+        </p:nvSpPr>
+        <p:spPr>
+          <a:xfrm>
+            <a:off x="731520" y="457200"/>
+            <a:ext cx="10058400" cy="457200"/>
+          </a:xfrm>
+          <a:prstGeom prst="rect">
+            <a:avLst/>
+          </a:prstGeom>
+          <a:noFill/>
+        </p:spPr>
+        <p:txBody>
+          <a:bodyPr wrap="square">
+            <a:spAutoFit/>
+          </a:bodyPr>
+          <a:lstStyle/>
+          <a:p>
+            <a:r>
+              <a:rPr sz="1400" b="1">
+                <a:solidFill>
+                  <a:srgbClr val="A58948"/>
+                </a:solidFill>
+                <a:latin typeface="Arial"/>
+              </a:rPr>
+              <a:t>PROOF, NOT PROMISES</a:t>
+            </a:r>
+          </a:p>
+        </p:txBody>
+      </p:sp>
+      <p:sp>
+        <p:nvSpPr>
+          <p:cNvPr id="3" name="TextBox 2"/>
+          <p:cNvSpPr txBox="1"/>
+          <p:nvPr/>
+        </p:nvSpPr>
+        <p:spPr>
+          <a:xfrm>
+            <a:off x="731520" y="822960"/>
+            <a:ext cx="10789920" cy="914400"/>
+          </a:xfrm>
+          <a:prstGeom prst="rect">
+            <a:avLst/>
+          </a:prstGeom>
+          <a:noFill/>
+        </p:spPr>
+        <p:txBody>
+          <a:bodyPr wrap="square">
+            <a:spAutoFit/>
+          </a:bodyPr>
+          <a:lstStyle/>
+          <a:p>
+            <a:r>
+              <a:rPr sz="4400" b="1">
+                <a:solidFill>
+                  <a:srgbClr val="14253D"/>
+                </a:solidFill>
+                <a:latin typeface="Georgia"/>
+              </a:rPr>
+              <a:t>Devin shows its work.</a:t>
+            </a:r>
+          </a:p>
+        </p:txBody>
+      </p:sp>
+      <p:sp>
+        <p:nvSpPr>
+          <p:cNvPr id="4" name="Rectangle 3"/>
+          <p:cNvSpPr/>
+          <p:nvPr/>
+        </p:nvSpPr>
+        <p:spPr>
+          <a:xfrm>
+            <a:off x="694944" y="1837943"/>
+            <a:ext cx="5074310" cy="4553712"/>
+          </a:xfrm>
+          <a:prstGeom prst="rect">
+            <a:avLst/>
+          </a:prstGeom>
+          <a:solidFill>
+            <a:srgbClr val="D9D2C3"/>
+          </a:solidFill>
+          <a:ln>
+            <a:noFill/>
+          </a:ln>
+          <a:effectLst/>
+        </p:spPr>
+        <p:style>
+          <a:lnRef idx="1">
+            <a:schemeClr val="accent1"/>
+          </a:lnRef>
+          <a:fillRef idx="3">
+            <a:schemeClr val="accent1"/>
+          </a:fillRef>
+          <a:effectRef idx="2">
+            <a:schemeClr val="accent1"/>
+          </a:effectRef>
+          <a:fontRef idx="minor">
+            <a:schemeClr val="lt1"/>
+          </a:fontRef>
+        </p:style>
+        <p:txBody>
+          <a:bodyPr rtlCol="0" anchor="ctr"/>
+          <a:lstStyle/>
+          <a:p>
+            <a:pPr algn="ctr"/>
+          </a:p>
+        </p:txBody>
+      </p:sp>
+      <p:pic>
+        <p:nvPicPr>
+          <p:cNvPr id="5" name="Picture 4" descr="c_compare.png"/>
+          <p:cNvPicPr>
+            <a:picLocks noChangeAspect="1"/>
+          </p:cNvPicPr>
+          <p:nvPr/>
+        </p:nvPicPr>
+        <p:blipFill>
+          <a:blip r:embed="rId2"/>
+          <a:stretch>
+            <a:fillRect/>
+          </a:stretch>
+        </p:blipFill>
+        <p:spPr>
+          <a:xfrm>
+            <a:off x="731520" y="1874519"/>
+            <a:ext cx="5001158" cy="4480560"/>
+          </a:xfrm>
+          <a:prstGeom prst="rect">
+            <a:avLst/>
+          </a:prstGeom>
+        </p:spPr>
+      </p:pic>
+      <p:sp>
+        <p:nvSpPr>
+          <p:cNvPr id="6" name="TextBox 5"/>
+          <p:cNvSpPr txBox="1"/>
+          <p:nvPr/>
+        </p:nvSpPr>
+        <p:spPr>
+          <a:xfrm>
+            <a:off x="6995160" y="2011680"/>
+            <a:ext cx="4572000" cy="4114800"/>
+          </a:xfrm>
+          <a:prstGeom prst="rect">
+            <a:avLst/>
+          </a:prstGeom>
+          <a:noFill/>
+        </p:spPr>
+        <p:txBody>
+          <a:bodyPr wrap="square">
+            <a:spAutoFit/>
+          </a:bodyPr>
+          <a:lstStyle/>
+          <a:p>
+            <a:r>
+              <a:rPr sz="2000" b="0">
+                <a:solidFill>
+                  <a:srgbClr val="14253D"/>
+                </a:solidFill>
+                <a:latin typeface="Arial"/>
+              </a:rPr>
+              <a:t>• Screenshot before the fix: 2 burgers, $12.50</a:t>
+            </a:r>
+          </a:p>
+          <a:p>
+            <a:pPr>
+              <a:spcBef>
+                <a:spcPts val="900"/>
+              </a:spcBef>
+            </a:pPr>
+            <a:r>
+              <a:rPr sz="2000" b="0">
+                <a:solidFill>
+                  <a:srgbClr val="14253D"/>
+                </a:solidFill>
+                <a:latin typeface="Arial"/>
+              </a:rPr>
+              <a:t>• Screenshot after the fix: $25.00</a:t>
+            </a:r>
+          </a:p>
+          <a:p>
+            <a:pPr>
+              <a:spcBef>
+                <a:spcPts val="900"/>
+              </a:spcBef>
+            </a:pPr>
+            <a:r>
+              <a:rPr sz="2000" b="0">
+                <a:solidFill>
+                  <a:srgbClr val="14253D"/>
+                </a:solidFill>
+                <a:latin typeface="Arial"/>
+              </a:rPr>
+              <a:t>• Root cause in plain English</a:t>
+            </a:r>
+          </a:p>
+          <a:p>
+            <a:pPr>
+              <a:spcBef>
+                <a:spcPts val="900"/>
+              </a:spcBef>
+            </a:pPr>
+            <a:r>
+              <a:rPr sz="2000" b="0">
+                <a:solidFill>
+                  <a:srgbClr val="14253D"/>
+                </a:solidFill>
+                <a:latin typeface="Arial"/>
+              </a:rPr>
+              <a:t>• The one-line diff in the PR</a:t>
+            </a:r>
+          </a:p>
+          <a:p>
+            <a:pPr>
+              <a:spcBef>
+                <a:spcPts val="900"/>
+              </a:spcBef>
+            </a:pPr>
+            <a:r>
+              <a:rPr sz="2000" b="0">
+                <a:solidFill>
+                  <a:srgbClr val="14253D"/>
+                </a:solidFill>
+                <a:latin typeface="Arial"/>
+              </a:rPr>
+              <a:t>• Click any image to go full screen</a:t>
+            </a:r>
+          </a:p>
+        </p:txBody>
+      </p:sp>
+      <p:sp>
+        <p:nvSpPr>
+          <p:cNvPr id="7" name="TextBox 6"/>
+          <p:cNvSpPr txBox="1"/>
+          <p:nvPr/>
+        </p:nvSpPr>
+        <p:spPr>
+          <a:xfrm>
+            <a:off x="6995160" y="5394960"/>
+            <a:ext cx="4572000" cy="914400"/>
+          </a:xfrm>
+          <a:prstGeom prst="rect">
+            <a:avLst/>
+          </a:prstGeom>
+          <a:noFill/>
+        </p:spPr>
+        <p:txBody>
+          <a:bodyPr wrap="square">
+            <a:spAutoFit/>
+          </a:bodyPr>
+          <a:lstStyle/>
+          <a:p>
+            <a:r>
+              <a:rPr sz="1600" b="1">
+                <a:solidFill>
+                  <a:srgbClr val="A58948"/>
+                </a:solidFill>
+                <a:latin typeface="Arial"/>
+              </a:rPr>
+              <a:t>A human reviews and merges. Nothing ships on its own.</a:t>
+            </a:r>
+          </a:p>
+        </p:txBody>
+      </p:sp>
+    </p:spTree>
+  </p:cSld>
+  <p:clrMapOvr>
+    <a:masterClrMapping/>
+  </p:clrMapOvr>
+</p:sld>
+</file>
+
+<file path=ppt/slides/slide8.xml><?xml version="1.0" encoding="utf-8"?>
+<p:sld xmlns:a="http://schemas.openxmlformats.org/drawingml/2006/main" xmlns:p="http://schemas.openxmlformats.org/presentationml/2006/main" xmlns:r="http://schemas.openxmlformats.org/officeDocument/2006/relationships">
+  <p:cSld>
+    <p:bg>
+      <p:bgPr>
+        <a:solidFill>
+          <a:srgbClr val="F8F5EE"/>
+        </a:solidFill>
+        <a:effectLst/>
+      </p:bgPr>
+    </p:bg>
+    <p:spTree>
+      <p:nvGrpSpPr>
+        <p:cNvPr id="1" name=""/>
+        <p:cNvGrpSpPr/>
+        <p:nvPr/>
+      </p:nvGrpSpPr>
+      <p:grpSpPr/>
+      <p:sp>
+        <p:nvSpPr>
+          <p:cNvPr id="2" name="TextBox 1"/>
+          <p:cNvSpPr txBox="1"/>
+          <p:nvPr/>
+        </p:nvSpPr>
+        <p:spPr>
+          <a:xfrm>
+            <a:off x="731520" y="457200"/>
+            <a:ext cx="10058400" cy="457200"/>
+          </a:xfrm>
+          <a:prstGeom prst="rect">
+            <a:avLst/>
+          </a:prstGeom>
+          <a:noFill/>
+        </p:spPr>
+        <p:txBody>
+          <a:bodyPr wrap="square">
+            <a:spAutoFit/>
+          </a:bodyPr>
+          <a:lstStyle/>
+          <a:p>
+            <a:r>
+              <a:rPr sz="1400" b="1">
+                <a:solidFill>
+                  <a:srgbClr val="A58948"/>
+                </a:solidFill>
+                <a:latin typeface="Arial"/>
+              </a:rPr>
+              <a:t>NOT A ONE-OFF</a:t>
+            </a:r>
+          </a:p>
+        </p:txBody>
+      </p:sp>
+      <p:sp>
+        <p:nvSpPr>
+          <p:cNvPr id="3" name="TextBox 2"/>
+          <p:cNvSpPr txBox="1"/>
+          <p:nvPr/>
+        </p:nvSpPr>
+        <p:spPr>
+          <a:xfrm>
+            <a:off x="731520" y="822960"/>
+            <a:ext cx="10789920" cy="914400"/>
+          </a:xfrm>
+          <a:prstGeom prst="rect">
+            <a:avLst/>
+          </a:prstGeom>
+          <a:noFill/>
+        </p:spPr>
+        <p:txBody>
+          <a:bodyPr wrap="square">
+            <a:spAutoFit/>
+          </a:bodyPr>
+          <a:lstStyle/>
+          <a:p>
+            <a:r>
+              <a:rPr sz="4400" b="1">
+                <a:solidFill>
+                  <a:srgbClr val="14253D"/>
+                </a:solidFill>
+                <a:latin typeface="Georgia"/>
+              </a:rPr>
+              <a:t>Six real runs, six real PRs.</a:t>
+            </a:r>
+          </a:p>
+        </p:txBody>
+      </p:sp>
+      <p:sp>
+        <p:nvSpPr>
+          <p:cNvPr id="4" name="TextBox 3"/>
+          <p:cNvSpPr txBox="1"/>
+          <p:nvPr/>
+        </p:nvSpPr>
+        <p:spPr>
+          <a:xfrm>
+            <a:off x="731520" y="1965960"/>
+            <a:ext cx="822960" cy="457200"/>
+          </a:xfrm>
+          <a:prstGeom prst="rect">
+            <a:avLst/>
+          </a:prstGeom>
+          <a:noFill/>
+        </p:spPr>
+        <p:txBody>
+          <a:bodyPr wrap="square">
+            <a:spAutoFit/>
+          </a:bodyPr>
+          <a:lstStyle/>
+          <a:p>
+            <a:r>
+              <a:rPr sz="2000" b="1">
+                <a:solidFill>
+                  <a:srgbClr val="A58948"/>
+                </a:solidFill>
+                <a:latin typeface="Arial"/>
+              </a:rPr>
+              <a:t>#14</a:t>
+            </a:r>
+          </a:p>
+        </p:txBody>
+      </p:sp>
+      <p:sp>
+        <p:nvSpPr>
+          <p:cNvPr id="5" name="TextBox 4"/>
+          <p:cNvSpPr txBox="1"/>
+          <p:nvPr/>
+        </p:nvSpPr>
+        <p:spPr>
+          <a:xfrm>
+            <a:off x="1554480" y="1965960"/>
+            <a:ext cx="3566160" cy="457200"/>
+          </a:xfrm>
+          <a:prstGeom prst="rect">
+            <a:avLst/>
+          </a:prstGeom>
+          <a:noFill/>
+        </p:spPr>
+        <p:txBody>
+          <a:bodyPr wrap="square">
+            <a:spAutoFit/>
+          </a:bodyPr>
+          <a:lstStyle/>
+          <a:p>
+            <a:r>
+              <a:rPr sz="1800" b="1">
+                <a:solidFill>
+                  <a:srgbClr val="14253D"/>
+                </a:solidFill>
+                <a:latin typeface="Arial"/>
+              </a:rPr>
+              <a:t>Bug 1 · via “Report a bug”</a:t>
+            </a:r>
+          </a:p>
+        </p:txBody>
+      </p:sp>
+      <p:sp>
+        <p:nvSpPr>
+          <p:cNvPr id="6" name="TextBox 5"/>
+          <p:cNvSpPr txBox="1"/>
+          <p:nvPr/>
+        </p:nvSpPr>
+        <p:spPr>
+          <a:xfrm>
+            <a:off x="1554480" y="2313432"/>
+            <a:ext cx="3566160" cy="411480"/>
+          </a:xfrm>
+          <a:prstGeom prst="rect">
+            <a:avLst/>
+          </a:prstGeom>
+          <a:noFill/>
+        </p:spPr>
+        <p:txBody>
+          <a:bodyPr wrap="square">
+            <a:spAutoFit/>
+          </a:bodyPr>
+          <a:lstStyle/>
+          <a:p>
+            <a:r>
+              <a:rPr sz="1400" b="0">
+                <a:solidFill>
+                  <a:srgbClr val="6B7685"/>
+                </a:solidFill>
+                <a:latin typeface="Arial"/>
+              </a:rPr>
+              <a:t>PR in 1m 24s</a:t>
+            </a:r>
+          </a:p>
+        </p:txBody>
+      </p:sp>
+      <p:sp>
+        <p:nvSpPr>
+          <p:cNvPr id="7" name="TextBox 6"/>
+          <p:cNvSpPr txBox="1"/>
+          <p:nvPr/>
+        </p:nvSpPr>
+        <p:spPr>
+          <a:xfrm>
+            <a:off x="731520" y="2624328"/>
+            <a:ext cx="822960" cy="457200"/>
+          </a:xfrm>
+          <a:prstGeom prst="rect">
+            <a:avLst/>
+          </a:prstGeom>
+          <a:noFill/>
+        </p:spPr>
+        <p:txBody>
+          <a:bodyPr wrap="square">
+            <a:spAutoFit/>
+          </a:bodyPr>
+          <a:lstStyle/>
+          <a:p>
+            <a:r>
+              <a:rPr sz="2000" b="1">
+                <a:solidFill>
+                  <a:srgbClr val="A58948"/>
+                </a:solidFill>
+                <a:latin typeface="Arial"/>
+              </a:rPr>
+              <a:t>#13</a:t>
+            </a:r>
+          </a:p>
+        </p:txBody>
+      </p:sp>
+      <p:sp>
+        <p:nvSpPr>
+          <p:cNvPr id="8" name="TextBox 7"/>
+          <p:cNvSpPr txBox="1"/>
+          <p:nvPr/>
+        </p:nvSpPr>
+        <p:spPr>
+          <a:xfrm>
+            <a:off x="1554480" y="2624328"/>
+            <a:ext cx="3566160" cy="457200"/>
+          </a:xfrm>
+          <a:prstGeom prst="rect">
+            <a:avLst/>
+          </a:prstGeom>
+          <a:noFill/>
+        </p:spPr>
+        <p:txBody>
+          <a:bodyPr wrap="square">
+            <a:spAutoFit/>
+          </a:bodyPr>
+          <a:lstStyle/>
+          <a:p>
+            <a:r>
+              <a:rPr sz="1800" b="1">
+                <a:solidFill>
+                  <a:srgbClr val="14253D"/>
+                </a:solidFill>
+                <a:latin typeface="Arial"/>
+              </a:rPr>
+              <a:t>Bug 1 · burger qty</a:t>
+            </a:r>
+          </a:p>
+        </p:txBody>
+      </p:sp>
+      <p:sp>
+        <p:nvSpPr>
+          <p:cNvPr id="9" name="TextBox 8"/>
+          <p:cNvSpPr txBox="1"/>
+          <p:nvPr/>
+        </p:nvSpPr>
+        <p:spPr>
+          <a:xfrm>
+            <a:off x="1554480" y="2971800"/>
+            <a:ext cx="3566160" cy="411480"/>
+          </a:xfrm>
+          <a:prstGeom prst="rect">
+            <a:avLst/>
+          </a:prstGeom>
+          <a:noFill/>
+        </p:spPr>
+        <p:txBody>
+          <a:bodyPr wrap="square">
+            <a:spAutoFit/>
+          </a:bodyPr>
+          <a:lstStyle/>
+          <a:p>
+            <a:r>
+              <a:rPr sz="1400" b="0">
+                <a:solidFill>
+                  <a:srgbClr val="6B7685"/>
+                </a:solidFill>
+                <a:latin typeface="Arial"/>
+              </a:rPr>
+              <a:t>PR in 1m 25s</a:t>
+            </a:r>
+          </a:p>
+        </p:txBody>
+      </p:sp>
+      <p:sp>
+        <p:nvSpPr>
+          <p:cNvPr id="10" name="TextBox 9"/>
+          <p:cNvSpPr txBox="1"/>
+          <p:nvPr/>
+        </p:nvSpPr>
+        <p:spPr>
+          <a:xfrm>
+            <a:off x="731520" y="3282696"/>
+            <a:ext cx="822960" cy="457200"/>
+          </a:xfrm>
+          <a:prstGeom prst="rect">
+            <a:avLst/>
+          </a:prstGeom>
+          <a:noFill/>
+        </p:spPr>
+        <p:txBody>
+          <a:bodyPr wrap="square">
+            <a:spAutoFit/>
+          </a:bodyPr>
+          <a:lstStyle/>
+          <a:p>
+            <a:r>
+              <a:rPr sz="2000" b="1">
+                <a:solidFill>
+                  <a:srgbClr val="A58948"/>
+                </a:solidFill>
+                <a:latin typeface="Arial"/>
+              </a:rPr>
+              <a:t>#8</a:t>
+            </a:r>
+          </a:p>
+        </p:txBody>
+      </p:sp>
+      <p:sp>
+        <p:nvSpPr>
+          <p:cNvPr id="11" name="TextBox 10"/>
+          <p:cNvSpPr txBox="1"/>
+          <p:nvPr/>
+        </p:nvSpPr>
+        <p:spPr>
+          <a:xfrm>
+            <a:off x="1554480" y="3282696"/>
+            <a:ext cx="3566160" cy="457200"/>
+          </a:xfrm>
+          <a:prstGeom prst="rect">
+            <a:avLst/>
+          </a:prstGeom>
+          <a:noFill/>
+        </p:spPr>
+        <p:txBody>
+          <a:bodyPr wrap="square">
+            <a:spAutoFit/>
+          </a:bodyPr>
+          <a:lstStyle/>
+          <a:p>
+            <a:r>
+              <a:rPr sz="1800" b="1">
+                <a:solidFill>
+                  <a:srgbClr val="14253D"/>
+                </a:solidFill>
+                <a:latin typeface="Arial"/>
+              </a:rPr>
+              <a:t>Bug 1 · burger qty</a:t>
+            </a:r>
+          </a:p>
+        </p:txBody>
+      </p:sp>
+      <p:sp>
+        <p:nvSpPr>
+          <p:cNvPr id="12" name="TextBox 11"/>
+          <p:cNvSpPr txBox="1"/>
+          <p:nvPr/>
+        </p:nvSpPr>
+        <p:spPr>
+          <a:xfrm>
+            <a:off x="1554480" y="3630168"/>
+            <a:ext cx="3566160" cy="411480"/>
+          </a:xfrm>
+          <a:prstGeom prst="rect">
+            <a:avLst/>
+          </a:prstGeom>
+          <a:noFill/>
+        </p:spPr>
+        <p:txBody>
+          <a:bodyPr wrap="square">
+            <a:spAutoFit/>
+          </a:bodyPr>
+          <a:lstStyle/>
+          <a:p>
+            <a:r>
+              <a:rPr sz="1400" b="0">
+                <a:solidFill>
+                  <a:srgbClr val="6B7685"/>
+                </a:solidFill>
+                <a:latin typeface="Arial"/>
+              </a:rPr>
+              <a:t>PR in 1m 35s</a:t>
+            </a:r>
+          </a:p>
+        </p:txBody>
+      </p:sp>
+      <p:sp>
+        <p:nvSpPr>
+          <p:cNvPr id="13" name="TextBox 12"/>
+          <p:cNvSpPr txBox="1"/>
+          <p:nvPr/>
+        </p:nvSpPr>
+        <p:spPr>
+          <a:xfrm>
+            <a:off x="731520" y="3941063"/>
+            <a:ext cx="822960" cy="457200"/>
+          </a:xfrm>
+          <a:prstGeom prst="rect">
+            <a:avLst/>
+          </a:prstGeom>
+          <a:noFill/>
+        </p:spPr>
+        <p:txBody>
+          <a:bodyPr wrap="square">
+            <a:spAutoFit/>
+          </a:bodyPr>
+          <a:lstStyle/>
+          <a:p>
+            <a:r>
+              <a:rPr sz="2000" b="1">
+                <a:solidFill>
+                  <a:srgbClr val="A58948"/>
+                </a:solidFill>
+                <a:latin typeface="Arial"/>
+              </a:rPr>
+              <a:t>#4</a:t>
+            </a:r>
+          </a:p>
+        </p:txBody>
+      </p:sp>
+      <p:sp>
+        <p:nvSpPr>
+          <p:cNvPr id="14" name="TextBox 13"/>
+          <p:cNvSpPr txBox="1"/>
+          <p:nvPr/>
+        </p:nvSpPr>
+        <p:spPr>
+          <a:xfrm>
+            <a:off x="1554480" y="3941063"/>
+            <a:ext cx="3566160" cy="457200"/>
+          </a:xfrm>
+          <a:prstGeom prst="rect">
+            <a:avLst/>
+          </a:prstGeom>
+          <a:noFill/>
+        </p:spPr>
+        <p:txBody>
+          <a:bodyPr wrap="square">
+            <a:spAutoFit/>
+          </a:bodyPr>
+          <a:lstStyle/>
+          <a:p>
+            <a:r>
+              <a:rPr sz="1800" b="1">
+                <a:solidFill>
+                  <a:srgbClr val="14253D"/>
+                </a:solidFill>
+                <a:latin typeface="Arial"/>
+              </a:rPr>
+              <a:t>Bug 3 · multi-word search</a:t>
+            </a:r>
+          </a:p>
+        </p:txBody>
+      </p:sp>
+      <p:sp>
+        <p:nvSpPr>
+          <p:cNvPr id="15" name="TextBox 14"/>
+          <p:cNvSpPr txBox="1"/>
+          <p:nvPr/>
+        </p:nvSpPr>
+        <p:spPr>
+          <a:xfrm>
+            <a:off x="1554480" y="4288536"/>
+            <a:ext cx="3566160" cy="411480"/>
+          </a:xfrm>
+          <a:prstGeom prst="rect">
+            <a:avLst/>
+          </a:prstGeom>
+          <a:noFill/>
+        </p:spPr>
+        <p:txBody>
+          <a:bodyPr wrap="square">
+            <a:spAutoFit/>
+          </a:bodyPr>
+          <a:lstStyle/>
+          <a:p>
+            <a:r>
+              <a:rPr sz="1400" b="0">
+                <a:solidFill>
+                  <a:srgbClr val="6B7685"/>
+                </a:solidFill>
+                <a:latin typeface="Arial"/>
+              </a:rPr>
+              <a:t>PR in ~1m, frames only</a:t>
+            </a:r>
+          </a:p>
+        </p:txBody>
+      </p:sp>
+      <p:sp>
+        <p:nvSpPr>
+          <p:cNvPr id="16" name="TextBox 15"/>
+          <p:cNvSpPr txBox="1"/>
+          <p:nvPr/>
+        </p:nvSpPr>
+        <p:spPr>
+          <a:xfrm>
+            <a:off x="731520" y="4599431"/>
+            <a:ext cx="822960" cy="457200"/>
+          </a:xfrm>
+          <a:prstGeom prst="rect">
+            <a:avLst/>
+          </a:prstGeom>
+          <a:noFill/>
+        </p:spPr>
+        <p:txBody>
+          <a:bodyPr wrap="square">
+            <a:spAutoFit/>
+          </a:bodyPr>
+          <a:lstStyle/>
+          <a:p>
+            <a:r>
+              <a:rPr sz="2000" b="1">
+                <a:solidFill>
+                  <a:srgbClr val="A58948"/>
+                </a:solidFill>
+                <a:latin typeface="Arial"/>
+              </a:rPr>
+              <a:t>#2</a:t>
+            </a:r>
+          </a:p>
+        </p:txBody>
+      </p:sp>
+      <p:sp>
+        <p:nvSpPr>
+          <p:cNvPr id="17" name="TextBox 16"/>
+          <p:cNvSpPr txBox="1"/>
+          <p:nvPr/>
+        </p:nvSpPr>
+        <p:spPr>
+          <a:xfrm>
+            <a:off x="1554480" y="4599431"/>
+            <a:ext cx="3566160" cy="457200"/>
+          </a:xfrm>
+          <a:prstGeom prst="rect">
+            <a:avLst/>
+          </a:prstGeom>
+          <a:noFill/>
+        </p:spPr>
+        <p:txBody>
+          <a:bodyPr wrap="square">
+            <a:spAutoFit/>
+          </a:bodyPr>
+          <a:lstStyle/>
+          <a:p>
+            <a:r>
+              <a:rPr sz="1800" b="1">
+                <a:solidFill>
+                  <a:srgbClr val="14253D"/>
+                </a:solidFill>
+                <a:latin typeface="Arial"/>
+              </a:rPr>
+              <a:t>Bug 1 · first run</a:t>
+            </a:r>
+          </a:p>
+        </p:txBody>
+      </p:sp>
+      <p:sp>
+        <p:nvSpPr>
+          <p:cNvPr id="18" name="TextBox 17"/>
+          <p:cNvSpPr txBox="1"/>
+          <p:nvPr/>
+        </p:nvSpPr>
+        <p:spPr>
+          <a:xfrm>
+            <a:off x="1554480" y="4946903"/>
+            <a:ext cx="3566160" cy="411480"/>
+          </a:xfrm>
+          <a:prstGeom prst="rect">
+            <a:avLst/>
+          </a:prstGeom>
+          <a:noFill/>
+        </p:spPr>
+        <p:txBody>
+          <a:bodyPr wrap="square">
+            <a:spAutoFit/>
+          </a:bodyPr>
+          <a:lstStyle/>
+          <a:p>
+            <a:r>
+              <a:rPr sz="1400" b="0">
+                <a:solidFill>
+                  <a:srgbClr val="6B7685"/>
+                </a:solidFill>
+                <a:latin typeface="Arial"/>
+              </a:rPr>
+              <a:t>one-line fix</a:t>
+            </a:r>
+          </a:p>
+        </p:txBody>
+      </p:sp>
+      <p:sp>
+        <p:nvSpPr>
+          <p:cNvPr id="19" name="TextBox 18"/>
+          <p:cNvSpPr txBox="1"/>
+          <p:nvPr/>
+        </p:nvSpPr>
+        <p:spPr>
+          <a:xfrm>
+            <a:off x="731520" y="5257799"/>
+            <a:ext cx="822960" cy="457200"/>
+          </a:xfrm>
+          <a:prstGeom prst="rect">
+            <a:avLst/>
+          </a:prstGeom>
+          <a:noFill/>
+        </p:spPr>
+        <p:txBody>
+          <a:bodyPr wrap="square">
+            <a:spAutoFit/>
+          </a:bodyPr>
+          <a:lstStyle/>
+          <a:p>
+            <a:r>
+              <a:rPr sz="2000" b="1">
+                <a:solidFill>
+                  <a:srgbClr val="A58948"/>
+                </a:solidFill>
+                <a:latin typeface="Arial"/>
+              </a:rPr>
+              <a:t>#7</a:t>
+            </a:r>
+          </a:p>
+        </p:txBody>
+      </p:sp>
+      <p:sp>
+        <p:nvSpPr>
+          <p:cNvPr id="20" name="TextBox 19"/>
+          <p:cNvSpPr txBox="1"/>
+          <p:nvPr/>
+        </p:nvSpPr>
+        <p:spPr>
+          <a:xfrm>
+            <a:off x="1554480" y="5257799"/>
+            <a:ext cx="3566160" cy="457200"/>
+          </a:xfrm>
+          <a:prstGeom prst="rect">
+            <a:avLst/>
+          </a:prstGeom>
+          <a:noFill/>
+        </p:spPr>
+        <p:txBody>
+          <a:bodyPr wrap="square">
+            <a:spAutoFit/>
+          </a:bodyPr>
+          <a:lstStyle/>
+          <a:p>
+            <a:r>
+              <a:rPr sz="1800" b="1">
+                <a:solidFill>
+                  <a:srgbClr val="14253D"/>
+                </a:solidFill>
+                <a:latin typeface="Arial"/>
+              </a:rPr>
+              <a:t>Bug 4 · double order</a:t>
+            </a:r>
+          </a:p>
+        </p:txBody>
+      </p:sp>
+      <p:sp>
+        <p:nvSpPr>
+          <p:cNvPr id="21" name="TextBox 20"/>
+          <p:cNvSpPr txBox="1"/>
+          <p:nvPr/>
+        </p:nvSpPr>
+        <p:spPr>
+          <a:xfrm>
+            <a:off x="1554480" y="5605271"/>
+            <a:ext cx="3566160" cy="411480"/>
+          </a:xfrm>
+          <a:prstGeom prst="rect">
+            <a:avLst/>
+          </a:prstGeom>
+          <a:noFill/>
+        </p:spPr>
+        <p:txBody>
+          <a:bodyPr wrap="square">
+            <a:spAutoFit/>
+          </a:bodyPr>
+          <a:lstStyle/>
+          <a:p>
+            <a:r>
+              <a:rPr sz="1400" b="0">
+                <a:solidFill>
+                  <a:srgbClr val="6B7685"/>
+                </a:solidFill>
+                <a:latin typeface="Arial"/>
+              </a:rPr>
+              <a:t>Devin read it as “cart not cleared”</a:t>
+            </a:r>
+          </a:p>
+        </p:txBody>
+      </p:sp>
+      <p:sp>
+        <p:nvSpPr>
+          <p:cNvPr id="22" name="TextBox 21"/>
+          <p:cNvSpPr txBox="1"/>
+          <p:nvPr/>
+        </p:nvSpPr>
+        <p:spPr>
+          <a:xfrm>
+            <a:off x="731520" y="5989320"/>
+            <a:ext cx="4572000" cy="548640"/>
+          </a:xfrm>
+          <a:prstGeom prst="rect">
+            <a:avLst/>
+          </a:prstGeom>
+          <a:noFill/>
+        </p:spPr>
+        <p:txBody>
+          <a:bodyPr wrap="square">
+            <a:spAutoFit/>
+          </a:bodyPr>
+          <a:lstStyle/>
+          <a:p>
+            <a:r>
+              <a:rPr sz="1600" b="1">
+                <a:solidFill>
+                  <a:srgbClr val="A58948"/>
+                </a:solidFill>
+                <a:latin typeface="Arial"/>
+              </a:rPr>
+              <a:t>#7 is why a human reviews every PR.</a:t>
+            </a:r>
+          </a:p>
+        </p:txBody>
+      </p:sp>
+      <p:sp>
+        <p:nvSpPr>
+          <p:cNvPr id="23" name="Rectangle 22"/>
+          <p:cNvSpPr/>
+          <p:nvPr/>
+        </p:nvSpPr>
+        <p:spPr>
+          <a:xfrm>
+            <a:off x="5449824" y="1883664"/>
+            <a:ext cx="6108192" cy="4850892"/>
+          </a:xfrm>
+          <a:prstGeom prst="rect">
+            <a:avLst/>
+          </a:prstGeom>
+          <a:solidFill>
+            <a:srgbClr val="D9D2C3"/>
+          </a:solidFill>
+          <a:ln>
+            <a:noFill/>
+          </a:ln>
+          <a:effectLst/>
+        </p:spPr>
+        <p:style>
+          <a:lnRef idx="1">
+            <a:schemeClr val="accent1"/>
+          </a:lnRef>
+          <a:fillRef idx="3">
+            <a:schemeClr val="accent1"/>
+          </a:fillRef>
+          <a:effectRef idx="2">
+            <a:schemeClr val="accent1"/>
+          </a:effectRef>
+          <a:fontRef idx="minor">
+            <a:schemeClr val="lt1"/>
+          </a:fontRef>
+        </p:style>
+        <p:txBody>
+          <a:bodyPr rtlCol="0" anchor="ctr"/>
+          <a:lstStyle/>
+          <a:p>
+            <a:pPr algn="ctr"/>
+          </a:p>
+        </p:txBody>
+      </p:sp>
+      <p:pic>
+        <p:nvPicPr>
+          <p:cNvPr id="24" name="Picture 23" descr="c_runs.png"/>
+          <p:cNvPicPr>
+            <a:picLocks noChangeAspect="1"/>
+          </p:cNvPicPr>
+          <p:nvPr/>
+        </p:nvPicPr>
+        <p:blipFill>
+          <a:blip r:embed="rId2"/>
+          <a:stretch>
+            <a:fillRect/>
+          </a:stretch>
+        </p:blipFill>
+        <p:spPr>
+          <a:xfrm>
+            <a:off x="5486400" y="1920240"/>
+            <a:ext cx="6035040" cy="4777740"/>
+          </a:xfrm>
+          <a:prstGeom prst="rect">
+            <a:avLst/>
+          </a:prstGeom>
+        </p:spPr>
+      </p:pic>
     </p:spTree>
   </p:cSld>
   <p:clrMapOvr>

</xml_diff>